<commit_message>
chore(preview): secteur_Technology_S&P_500 outputs regeneres
</commit_message>
<xml_diff>
--- a/preview/secteur_Technology_S&P_500/secteur_Technology_S&P_500.pptx
+++ b/preview/secteur_Technology_S&P_500/secteur_Technology_S&P_500.pptx
@@ -11934,7 +11934,7 @@
         </p:nvGraphicFramePr>
         <p:xfrm>
           <a:off x="324000" y="1260000"/>
-          <a:ext cx="8495997" cy="1814400"/>
+          <a:ext cx="8495997" cy="1782000"/>
         </p:xfrm>
         <a:graphic>
           <a:graphicData uri="http://schemas.openxmlformats.org/drawingml/2006/table">
@@ -11951,7 +11951,7 @@
                 <a:gridCol w="1607351"/>
                 <a:gridCol w="956756"/>
               </a:tblGrid>
-              <a:tr h="201600">
+              <a:tr h="198000">
                 <a:tc>
                   <a:txBody>
                     <a:bodyPr/>
@@ -12107,7 +12107,7 @@
                   </a:tcPr>
                 </a:tc>
               </a:tr>
-              <a:tr h="201600">
+              <a:tr h="198000">
                 <a:tc>
                   <a:txBody>
                     <a:bodyPr/>
@@ -12249,7 +12249,7 @@
                   </a:tcPr>
                 </a:tc>
               </a:tr>
-              <a:tr h="201600">
+              <a:tr h="198000">
                 <a:tc>
                   <a:txBody>
                     <a:bodyPr/>
@@ -12405,7 +12405,7 @@
                   </a:tcPr>
                 </a:tc>
               </a:tr>
-              <a:tr h="201600">
+              <a:tr h="198000">
                 <a:tc>
                   <a:txBody>
                     <a:bodyPr/>
@@ -12547,7 +12547,7 @@
                   </a:tcPr>
                 </a:tc>
               </a:tr>
-              <a:tr h="201600">
+              <a:tr h="198000">
                 <a:tc>
                   <a:txBody>
                     <a:bodyPr/>
@@ -12703,7 +12703,7 @@
                   </a:tcPr>
                 </a:tc>
               </a:tr>
-              <a:tr h="201600">
+              <a:tr h="198000">
                 <a:tc>
                   <a:txBody>
                     <a:bodyPr/>
@@ -12845,7 +12845,7 @@
                   </a:tcPr>
                 </a:tc>
               </a:tr>
-              <a:tr h="201600">
+              <a:tr h="198000">
                 <a:tc>
                   <a:txBody>
                     <a:bodyPr/>
@@ -13001,7 +13001,7 @@
                   </a:tcPr>
                 </a:tc>
               </a:tr>
-              <a:tr h="201600">
+              <a:tr h="198000">
                 <a:tc>
                   <a:txBody>
                     <a:bodyPr/>
@@ -13143,7 +13143,7 @@
                   </a:tcPr>
                 </a:tc>
               </a:tr>
-              <a:tr h="201600">
+              <a:tr h="198000">
                 <a:tc>
                   <a:txBody>
                     <a:bodyPr/>
@@ -13311,8 +13311,8 @@
         </p:nvSpPr>
         <p:spPr>
           <a:xfrm>
-            <a:off x="324000" y="2916000"/>
-            <a:ext cx="8496000" cy="1007999"/>
+            <a:off x="324000" y="3114000"/>
+            <a:ext cx="8496000" cy="576000"/>
           </a:xfrm>
           <a:prstGeom prst="rect">
             <a:avLst/>
@@ -13354,8 +13354,8 @@
         </p:nvSpPr>
         <p:spPr>
           <a:xfrm>
-            <a:off x="324000" y="2916000"/>
-            <a:ext cx="36000" cy="1007999"/>
+            <a:off x="324000" y="3114000"/>
+            <a:ext cx="36000" cy="576000"/>
           </a:xfrm>
           <a:prstGeom prst="rect">
             <a:avLst/>
@@ -13397,8 +13397,8 @@
         </p:nvSpPr>
         <p:spPr>
           <a:xfrm>
-            <a:off x="468000" y="2951999"/>
-            <a:ext cx="8316000" cy="216000"/>
+            <a:off x="468000" y="3142800"/>
+            <a:ext cx="8316000" cy="180000"/>
           </a:xfrm>
           <a:prstGeom prst="rect">
             <a:avLst/>
@@ -13413,7 +13413,7 @@
           <a:p>
             <a:pPr algn="l"/>
             <a:r>
-              <a:rPr sz="850" b="1" i="0">
+              <a:rPr sz="800" b="1" i="0">
                 <a:solidFill>
                   <a:srgbClr val="B06000"/>
                 </a:solidFill>
@@ -13431,8 +13431,8 @@
         </p:nvSpPr>
         <p:spPr>
           <a:xfrm>
-            <a:off x="468000" y="3186000"/>
-            <a:ext cx="8316000" cy="720000"/>
+            <a:off x="468000" y="3330000"/>
+            <a:ext cx="8316000" cy="324000"/>
           </a:xfrm>
           <a:prstGeom prst="rect">
             <a:avLst/>
@@ -13447,12 +13447,12 @@
           <a:p>
             <a:pPr algn="l"/>
             <a:r>
-              <a:rPr sz="800" b="0" i="0">
+              <a:rPr sz="750" b="0" i="0">
                 <a:solidFill>
                   <a:srgbClr val="555555"/>
                 </a:solidFill>
               </a:rPr>
-              <a:t>La probabilite de rendement positif a 12 mois est calculee sur des configurations similaires identifiees en backtesting sur données historiques (2010-2024). Elle ne constitue pas une garantie de performance future. Le DCF Base est estime a partir du WACC median sectoriel et d'un taux de croissance terminal cohérent avec les drivers sectoriels.</a:t>
+              <a:t>La probabilite de rendement positif a 12 mois est calculee sur des configurations similaires identifiees en backtesting sur donnees historiques (2010-2024). Elle ne constitue pas une garantie de performance future.</a:t>
             </a:r>
           </a:p>
         </p:txBody>
@@ -14861,7 +14861,7 @@
         <p:spPr>
           <a:xfrm>
             <a:off x="324000" y="900000"/>
-            <a:ext cx="2700000" cy="1980000"/>
+            <a:ext cx="2700000" cy="1152000"/>
           </a:xfrm>
           <a:prstGeom prst="rect">
             <a:avLst/>
@@ -14981,7 +14981,7 @@
         <p:spPr>
           <a:xfrm>
             <a:off x="396000" y="1188000"/>
-            <a:ext cx="2520000" cy="1620000"/>
+            <a:ext cx="2520000" cy="792000"/>
           </a:xfrm>
           <a:prstGeom prst="rect">
             <a:avLst/>
@@ -15015,7 +15015,7 @@
         <p:spPr>
           <a:xfrm>
             <a:off x="3240000" y="900000"/>
-            <a:ext cx="2700000" cy="1980000"/>
+            <a:ext cx="2700000" cy="1152000"/>
           </a:xfrm>
           <a:prstGeom prst="rect">
             <a:avLst/>
@@ -15135,7 +15135,7 @@
         <p:spPr>
           <a:xfrm>
             <a:off x="3311999" y="1188000"/>
-            <a:ext cx="2520000" cy="1620000"/>
+            <a:ext cx="2520000" cy="792000"/>
           </a:xfrm>
           <a:prstGeom prst="rect">
             <a:avLst/>
@@ -15169,7 +15169,7 @@
         <p:spPr>
           <a:xfrm>
             <a:off x="6155999" y="900000"/>
-            <a:ext cx="2700000" cy="1980000"/>
+            <a:ext cx="2700000" cy="1152000"/>
           </a:xfrm>
           <a:prstGeom prst="rect">
             <a:avLst/>
@@ -15289,7 +15289,7 @@
         <p:spPr>
           <a:xfrm>
             <a:off x="6227999" y="1188000"/>
-            <a:ext cx="2520000" cy="1620000"/>
+            <a:ext cx="2520000" cy="792000"/>
           </a:xfrm>
           <a:prstGeom prst="rect">
             <a:avLst/>
@@ -15322,7 +15322,7 @@
         </p:nvSpPr>
         <p:spPr>
           <a:xfrm>
-            <a:off x="324000" y="2951999"/>
+            <a:off x="324000" y="2196000"/>
             <a:ext cx="8496000" cy="216000"/>
           </a:xfrm>
           <a:prstGeom prst="rect">
@@ -15357,7 +15357,7 @@
           <p:nvPr/>
         </p:nvGraphicFramePr>
         <p:xfrm>
-          <a:off x="324000" y="3204000"/>
+          <a:off x="324000" y="2448000"/>
           <a:ext cx="8496000" cy="1116000"/>
         </p:xfrm>
         <a:graphic>
@@ -28453,7 +28453,7 @@
         </p:nvSpPr>
         <p:spPr>
           <a:xfrm>
-            <a:off x="324000" y="3780000"/>
+            <a:off x="324000" y="2988000"/>
             <a:ext cx="8496000" cy="1007999"/>
           </a:xfrm>
           <a:prstGeom prst="rect">
@@ -28496,7 +28496,7 @@
         </p:nvSpPr>
         <p:spPr>
           <a:xfrm>
-            <a:off x="324000" y="3780000"/>
+            <a:off x="324000" y="2988000"/>
             <a:ext cx="8496000" cy="251999"/>
           </a:xfrm>
           <a:prstGeom prst="rect">
@@ -28539,7 +28539,7 @@
         </p:nvSpPr>
         <p:spPr>
           <a:xfrm>
-            <a:off x="396000" y="3798000"/>
+            <a:off x="396000" y="3006000"/>
             <a:ext cx="8352000" cy="216000"/>
           </a:xfrm>
           <a:prstGeom prst="rect">
@@ -28573,7 +28573,7 @@
         </p:nvSpPr>
         <p:spPr>
           <a:xfrm>
-            <a:off x="396000" y="4068000"/>
+            <a:off x="396000" y="3276000"/>
             <a:ext cx="8352000" cy="720000"/>
           </a:xfrm>
           <a:prstGeom prst="rect">
@@ -28594,7 +28594,7 @@
                   <a:srgbClr val="555555"/>
                 </a:solidFill>
               </a:rPr>
-              <a:t>La médiane EV/EBITDA sectorielle s etablit a 20.5x LTM. Alphabet Inc. (21.7x) se distingue comme le leader de qualité, combine a une marge EBITDA de 37.3 % et une croissance de +18.0 %. La dispersion des multiples revele la hétérogénéité des profils au sein du secteur Technology — une lecture croisee P/E vs EV/EBITDA permet d'isoler les effets de structure de capital et les distorsions comptables.</a:t>
+              <a:t>La mediane EV/EBITDA sectorielle s etablit a 20.5x LTM. Alphabet Inc. (21.7x) se distingue comme le leader de qualite, combine a une marge EBITDA de 37.3 % et une croissance de +18.0 %. La dispersion des multiples revele l heterogeneite des profils au sein du secteur Technology — une lecture croisee P/E vs EV/EBITDA permet d isoler les effets de structure de capital et les distorsions comptables.</a:t>
             </a:r>
           </a:p>
         </p:txBody>
@@ -33057,8 +33057,8 @@
         </p:nvSpPr>
         <p:spPr>
           <a:xfrm>
-            <a:off x="324000" y="3348000"/>
-            <a:ext cx="8496000" cy="1440000"/>
+            <a:off x="324000" y="2822400"/>
+            <a:ext cx="8496000" cy="2037600"/>
           </a:xfrm>
           <a:prstGeom prst="rect">
             <a:avLst/>
@@ -33100,8 +33100,8 @@
         </p:nvSpPr>
         <p:spPr>
           <a:xfrm>
-            <a:off x="324000" y="3348000"/>
-            <a:ext cx="36000" cy="1440000"/>
+            <a:off x="324000" y="2822400"/>
+            <a:ext cx="36000" cy="2037600"/>
           </a:xfrm>
           <a:prstGeom prst="rect">
             <a:avLst/>
@@ -33143,7 +33143,7 @@
         </p:nvSpPr>
         <p:spPr>
           <a:xfrm>
-            <a:off x="468000" y="3401999"/>
+            <a:off x="468000" y="2876400"/>
             <a:ext cx="8280000" cy="216000"/>
           </a:xfrm>
           <a:prstGeom prst="rect">
@@ -33177,8 +33177,8 @@
         </p:nvSpPr>
         <p:spPr>
           <a:xfrm>
-            <a:off x="468000" y="3636000"/>
-            <a:ext cx="8280000" cy="1080000"/>
+            <a:off x="468000" y="3128400"/>
+            <a:ext cx="8280000" cy="1677600"/>
           </a:xfrm>
           <a:prstGeom prst="rect">
             <a:avLst/>

</xml_diff>